<commit_message>
Move the 45C threshold label outside the plot area on the example-week chart
</commit_message>
<xml_diff>
--- a/reports/poc_report.pptx
+++ b/reports/poc_report.pptx
@@ -5902,8 +5902,8 @@
         </p:blipFill>
         <p:spPr>
           <a:xfrm>
-            <a:off x="1181601" y="1679448"/>
-            <a:ext cx="9828493" cy="3017520"/>
+            <a:off x="704883" y="1679448"/>
+            <a:ext cx="10781928" cy="3017520"/>
           </a:xfrm>
           <a:prstGeom prst="rect">
             <a:avLst/>

</xml_diff>

<commit_message>
Make the MAE chart readable: evenly spaced horizons and an aligned improvement row
</commit_message>
<xml_diff>
--- a/reports/poc_report.pptx
+++ b/reports/poc_report.pptx
@@ -3529,8 +3529,8 @@
         </p:blipFill>
         <p:spPr>
           <a:xfrm>
-            <a:off x="2207227" y="1756918"/>
-            <a:ext cx="7777241" cy="2743200"/>
+            <a:off x="1947873" y="1756918"/>
+            <a:ext cx="8295948" cy="2880360"/>
           </a:xfrm>
           <a:prstGeom prst="rect">
             <a:avLst/>
@@ -3545,8 +3545,8 @@
         </p:nvSpPr>
         <p:spPr>
           <a:xfrm>
-            <a:off x="2157984" y="4774438"/>
-            <a:ext cx="2600553" cy="274320"/>
+            <a:off x="2157984" y="4911598"/>
+            <a:ext cx="2600553" cy="256032"/>
           </a:xfrm>
           <a:prstGeom prst="rect">
             <a:avLst/>
@@ -3592,8 +3592,8 @@
         </p:nvSpPr>
         <p:spPr>
           <a:xfrm>
-            <a:off x="4831689" y="4774438"/>
-            <a:ext cx="964874" cy="274320"/>
+            <a:off x="4831689" y="4911598"/>
+            <a:ext cx="964874" cy="256032"/>
           </a:xfrm>
           <a:prstGeom prst="rect">
             <a:avLst/>
@@ -3639,8 +3639,8 @@
         </p:nvSpPr>
         <p:spPr>
           <a:xfrm>
-            <a:off x="5869715" y="4774438"/>
-            <a:ext cx="964874" cy="274320"/>
+            <a:off x="5869715" y="4911598"/>
+            <a:ext cx="964874" cy="256032"/>
           </a:xfrm>
           <a:prstGeom prst="rect">
             <a:avLst/>
@@ -3686,8 +3686,8 @@
         </p:nvSpPr>
         <p:spPr>
           <a:xfrm>
-            <a:off x="6907741" y="4774438"/>
-            <a:ext cx="964874" cy="274320"/>
+            <a:off x="6907741" y="4911598"/>
+            <a:ext cx="964874" cy="256032"/>
           </a:xfrm>
           <a:prstGeom prst="rect">
             <a:avLst/>
@@ -3733,8 +3733,8 @@
         </p:nvSpPr>
         <p:spPr>
           <a:xfrm>
-            <a:off x="7945767" y="4774438"/>
-            <a:ext cx="964874" cy="274320"/>
+            <a:off x="7945767" y="4911598"/>
+            <a:ext cx="964874" cy="256032"/>
           </a:xfrm>
           <a:prstGeom prst="rect">
             <a:avLst/>
@@ -3780,8 +3780,8 @@
         </p:nvSpPr>
         <p:spPr>
           <a:xfrm>
-            <a:off x="8983793" y="4774438"/>
-            <a:ext cx="964874" cy="274320"/>
+            <a:off x="8983793" y="4911598"/>
+            <a:ext cx="964874" cy="256032"/>
           </a:xfrm>
           <a:prstGeom prst="rect">
             <a:avLst/>
@@ -3827,7 +3827,7 @@
         </p:nvSpPr>
         <p:spPr>
           <a:xfrm>
-            <a:off x="2121408" y="5021326"/>
+            <a:off x="2121408" y="5140198"/>
             <a:ext cx="7863840" cy="9525"/>
           </a:xfrm>
           <a:prstGeom prst="rect">
@@ -3871,8 +3871,8 @@
         </p:nvSpPr>
         <p:spPr>
           <a:xfrm>
-            <a:off x="2157984" y="5048758"/>
-            <a:ext cx="2600553" cy="274320"/>
+            <a:off x="2157984" y="5167630"/>
+            <a:ext cx="2600553" cy="256032"/>
           </a:xfrm>
           <a:prstGeom prst="rect">
             <a:avLst/>
@@ -3918,8 +3918,8 @@
         </p:nvSpPr>
         <p:spPr>
           <a:xfrm>
-            <a:off x="4831689" y="5048758"/>
-            <a:ext cx="964874" cy="274320"/>
+            <a:off x="4831689" y="5167630"/>
+            <a:ext cx="964874" cy="256032"/>
           </a:xfrm>
           <a:prstGeom prst="rect">
             <a:avLst/>
@@ -3965,8 +3965,8 @@
         </p:nvSpPr>
         <p:spPr>
           <a:xfrm>
-            <a:off x="5869715" y="5048758"/>
-            <a:ext cx="964874" cy="274320"/>
+            <a:off x="5869715" y="5167630"/>
+            <a:ext cx="964874" cy="256032"/>
           </a:xfrm>
           <a:prstGeom prst="rect">
             <a:avLst/>
@@ -4012,8 +4012,8 @@
         </p:nvSpPr>
         <p:spPr>
           <a:xfrm>
-            <a:off x="6907741" y="5048758"/>
-            <a:ext cx="964874" cy="274320"/>
+            <a:off x="6907741" y="5167630"/>
+            <a:ext cx="964874" cy="256032"/>
           </a:xfrm>
           <a:prstGeom prst="rect">
             <a:avLst/>
@@ -4059,8 +4059,8 @@
         </p:nvSpPr>
         <p:spPr>
           <a:xfrm>
-            <a:off x="7945767" y="5048758"/>
-            <a:ext cx="964874" cy="274320"/>
+            <a:off x="7945767" y="5167630"/>
+            <a:ext cx="964874" cy="256032"/>
           </a:xfrm>
           <a:prstGeom prst="rect">
             <a:avLst/>
@@ -4106,8 +4106,8 @@
         </p:nvSpPr>
         <p:spPr>
           <a:xfrm>
-            <a:off x="8983793" y="5048758"/>
-            <a:ext cx="964874" cy="274320"/>
+            <a:off x="8983793" y="5167630"/>
+            <a:ext cx="964874" cy="256032"/>
           </a:xfrm>
           <a:prstGeom prst="rect">
             <a:avLst/>
@@ -4153,8 +4153,8 @@
         </p:nvSpPr>
         <p:spPr>
           <a:xfrm>
-            <a:off x="2048256" y="5323078"/>
-            <a:ext cx="8010144" cy="274320"/>
+            <a:off x="2048256" y="5423662"/>
+            <a:ext cx="8010144" cy="256032"/>
           </a:xfrm>
           <a:prstGeom prst="roundRect">
             <a:avLst>
@@ -4199,8 +4199,8 @@
         </p:nvSpPr>
         <p:spPr>
           <a:xfrm>
-            <a:off x="2157984" y="5323078"/>
-            <a:ext cx="2600553" cy="274320"/>
+            <a:off x="2157984" y="5423662"/>
+            <a:ext cx="2600553" cy="256032"/>
           </a:xfrm>
           <a:prstGeom prst="rect">
             <a:avLst/>
@@ -4246,8 +4246,8 @@
         </p:nvSpPr>
         <p:spPr>
           <a:xfrm>
-            <a:off x="4831689" y="5323078"/>
-            <a:ext cx="964874" cy="274320"/>
+            <a:off x="4831689" y="5423662"/>
+            <a:ext cx="964874" cy="256032"/>
           </a:xfrm>
           <a:prstGeom prst="rect">
             <a:avLst/>
@@ -4293,8 +4293,8 @@
         </p:nvSpPr>
         <p:spPr>
           <a:xfrm>
-            <a:off x="5869715" y="5323078"/>
-            <a:ext cx="964874" cy="274320"/>
+            <a:off x="5869715" y="5423662"/>
+            <a:ext cx="964874" cy="256032"/>
           </a:xfrm>
           <a:prstGeom prst="rect">
             <a:avLst/>
@@ -4340,8 +4340,8 @@
         </p:nvSpPr>
         <p:spPr>
           <a:xfrm>
-            <a:off x="6907741" y="5323078"/>
-            <a:ext cx="964874" cy="274320"/>
+            <a:off x="6907741" y="5423662"/>
+            <a:ext cx="964874" cy="256032"/>
           </a:xfrm>
           <a:prstGeom prst="rect">
             <a:avLst/>
@@ -4387,8 +4387,8 @@
         </p:nvSpPr>
         <p:spPr>
           <a:xfrm>
-            <a:off x="7945767" y="5323078"/>
-            <a:ext cx="964874" cy="274320"/>
+            <a:off x="7945767" y="5423662"/>
+            <a:ext cx="964874" cy="256032"/>
           </a:xfrm>
           <a:prstGeom prst="rect">
             <a:avLst/>
@@ -4434,8 +4434,8 @@
         </p:nvSpPr>
         <p:spPr>
           <a:xfrm>
-            <a:off x="8983793" y="5323078"/>
-            <a:ext cx="964874" cy="274320"/>
+            <a:off x="8983793" y="5423662"/>
+            <a:ext cx="964874" cy="256032"/>
           </a:xfrm>
           <a:prstGeom prst="rect">
             <a:avLst/>
@@ -4481,8 +4481,8 @@
         </p:nvSpPr>
         <p:spPr>
           <a:xfrm>
-            <a:off x="2157984" y="5597398"/>
-            <a:ext cx="2600553" cy="274320"/>
+            <a:off x="2157984" y="5679694"/>
+            <a:ext cx="2600553" cy="256032"/>
           </a:xfrm>
           <a:prstGeom prst="rect">
             <a:avLst/>
@@ -4528,8 +4528,8 @@
         </p:nvSpPr>
         <p:spPr>
           <a:xfrm>
-            <a:off x="4831689" y="5597398"/>
-            <a:ext cx="964874" cy="274320"/>
+            <a:off x="4831689" y="5679694"/>
+            <a:ext cx="964874" cy="256032"/>
           </a:xfrm>
           <a:prstGeom prst="rect">
             <a:avLst/>
@@ -4575,8 +4575,8 @@
         </p:nvSpPr>
         <p:spPr>
           <a:xfrm>
-            <a:off x="5869715" y="5597398"/>
-            <a:ext cx="964874" cy="274320"/>
+            <a:off x="5869715" y="5679694"/>
+            <a:ext cx="964874" cy="256032"/>
           </a:xfrm>
           <a:prstGeom prst="rect">
             <a:avLst/>
@@ -4622,8 +4622,8 @@
         </p:nvSpPr>
         <p:spPr>
           <a:xfrm>
-            <a:off x="6907741" y="5597398"/>
-            <a:ext cx="964874" cy="274320"/>
+            <a:off x="6907741" y="5679694"/>
+            <a:ext cx="964874" cy="256032"/>
           </a:xfrm>
           <a:prstGeom prst="rect">
             <a:avLst/>
@@ -4669,8 +4669,8 @@
         </p:nvSpPr>
         <p:spPr>
           <a:xfrm>
-            <a:off x="7945767" y="5597398"/>
-            <a:ext cx="964874" cy="274320"/>
+            <a:off x="7945767" y="5679694"/>
+            <a:ext cx="964874" cy="256032"/>
           </a:xfrm>
           <a:prstGeom prst="rect">
             <a:avLst/>
@@ -4716,8 +4716,8 @@
         </p:nvSpPr>
         <p:spPr>
           <a:xfrm>
-            <a:off x="8983793" y="5597398"/>
-            <a:ext cx="964874" cy="274320"/>
+            <a:off x="8983793" y="5679694"/>
+            <a:ext cx="964874" cy="256032"/>
           </a:xfrm>
           <a:prstGeom prst="rect">
             <a:avLst/>
@@ -4763,8 +4763,8 @@
         </p:nvSpPr>
         <p:spPr>
           <a:xfrm>
-            <a:off x="2048256" y="5871718"/>
-            <a:ext cx="8010144" cy="274320"/>
+            <a:off x="2048256" y="5935726"/>
+            <a:ext cx="8010144" cy="256032"/>
           </a:xfrm>
           <a:prstGeom prst="roundRect">
             <a:avLst>
@@ -4809,8 +4809,8 @@
         </p:nvSpPr>
         <p:spPr>
           <a:xfrm>
-            <a:off x="2157984" y="5871718"/>
-            <a:ext cx="2600553" cy="274320"/>
+            <a:off x="2157984" y="5935726"/>
+            <a:ext cx="2600553" cy="256032"/>
           </a:xfrm>
           <a:prstGeom prst="rect">
             <a:avLst/>
@@ -4856,8 +4856,8 @@
         </p:nvSpPr>
         <p:spPr>
           <a:xfrm>
-            <a:off x="4831689" y="5871718"/>
-            <a:ext cx="964874" cy="274320"/>
+            <a:off x="4831689" y="5935726"/>
+            <a:ext cx="964874" cy="256032"/>
           </a:xfrm>
           <a:prstGeom prst="rect">
             <a:avLst/>
@@ -4903,8 +4903,8 @@
         </p:nvSpPr>
         <p:spPr>
           <a:xfrm>
-            <a:off x="5869715" y="5871718"/>
-            <a:ext cx="964874" cy="274320"/>
+            <a:off x="5869715" y="5935726"/>
+            <a:ext cx="964874" cy="256032"/>
           </a:xfrm>
           <a:prstGeom prst="rect">
             <a:avLst/>
@@ -4950,8 +4950,8 @@
         </p:nvSpPr>
         <p:spPr>
           <a:xfrm>
-            <a:off x="6907741" y="5871718"/>
-            <a:ext cx="964874" cy="274320"/>
+            <a:off x="6907741" y="5935726"/>
+            <a:ext cx="964874" cy="256032"/>
           </a:xfrm>
           <a:prstGeom prst="rect">
             <a:avLst/>
@@ -4997,8 +4997,8 @@
         </p:nvSpPr>
         <p:spPr>
           <a:xfrm>
-            <a:off x="7945767" y="5871718"/>
-            <a:ext cx="964874" cy="274320"/>
+            <a:off x="7945767" y="5935726"/>
+            <a:ext cx="964874" cy="256032"/>
           </a:xfrm>
           <a:prstGeom prst="rect">
             <a:avLst/>
@@ -5044,8 +5044,8 @@
         </p:nvSpPr>
         <p:spPr>
           <a:xfrm>
-            <a:off x="8983793" y="5871718"/>
-            <a:ext cx="964874" cy="274320"/>
+            <a:off x="8983793" y="5935726"/>
+            <a:ext cx="964874" cy="256032"/>
           </a:xfrm>
           <a:prstGeom prst="rect">
             <a:avLst/>
@@ -5091,7 +5091,7 @@
         </p:nvSpPr>
         <p:spPr>
           <a:xfrm>
-            <a:off x="566928" y="6292342"/>
+            <a:off x="566928" y="6338062"/>
             <a:ext cx="11057839" cy="166687"/>
           </a:xfrm>
           <a:prstGeom prst="rect">

</xml_diff>